<commit_message>
feat: add lab slot 14 lab 4
</commit_message>
<xml_diff>
--- a/slide/Chapter_04_DAT301m/4.3 Time series-Train, validation and test sets.pptx
+++ b/slide/Chapter_04_DAT301m/4.3 Time series-Train, validation and test sets.pptx
@@ -271,7 +271,7 @@
       </p15:sldGuideLst>
     </p:ext>
     <p:ext uri="GoogleSlidesCustomDataVersion2">
-      <go:slidesCustomData xmlns:go="http://customooxmlschemas.google.com/" xmlns:ahyp="http://schemas.microsoft.com/office/drawing/2018/hyperlinkcolor" xmlns:p15="http://schemas.microsoft.com/office/powerpoint/2012/main" xmlns:p14="http://schemas.microsoft.com/office/powerpoint/2010/main" xmlns:com="http://schemas.openxmlformats.org/drawingml/2006/compatibility" xmlns:pvml="urn:schemas-microsoft-com:office:powerpoint" xmlns:v="urn:schemas-microsoft-com:vml" xmlns:o="urn:schemas-microsoft-com:office:office" xmlns:dgm="http://schemas.openxmlformats.org/drawingml/2006/diagram" xmlns:c="http://schemas.openxmlformats.org/drawingml/2006/chart" xmlns:mv="urn:schemas-microsoft-com:mac:vml" xmlns:mc="http://schemas.openxmlformats.org/markup-compatibility/2006" xmlns="" r:id="rId23" roundtripDataSignature="AMtx7mi0NdMlgez3NH7Jju1J+fl80PbFdg=="/>
+      <go:slidesCustomData xmlns="" xmlns:mc="http://schemas.openxmlformats.org/markup-compatibility/2006" xmlns:mv="urn:schemas-microsoft-com:mac:vml" xmlns:c="http://schemas.openxmlformats.org/drawingml/2006/chart" xmlns:dgm="http://schemas.openxmlformats.org/drawingml/2006/diagram" xmlns:o="urn:schemas-microsoft-com:office:office" xmlns:v="urn:schemas-microsoft-com:vml" xmlns:pvml="urn:schemas-microsoft-com:office:powerpoint" xmlns:com="http://schemas.openxmlformats.org/drawingml/2006/compatibility" xmlns:p14="http://schemas.microsoft.com/office/powerpoint/2010/main" xmlns:p15="http://schemas.microsoft.com/office/powerpoint/2012/main" xmlns:ahyp="http://schemas.microsoft.com/office/drawing/2018/hyperlinkcolor" xmlns:go="http://customooxmlschemas.google.com/" r:id="rId23" roundtripDataSignature="AMtx7mi0NdMlgez3NH7Jju1J+fl80PbFdg=="/>
     </p:ext>
   </p:extLst>
 </p:presentation>
@@ -1863,7 +1863,7 @@
         </p:nvSpPr>
         <p:spPr>
           <a:xfrm>
-            <a:off x="1255712" y="720725"/>
+            <a:off x="1255713" y="720725"/>
             <a:ext cx="4792662" cy="3594100"/>
           </a:xfrm>
           <a:custGeom>
@@ -17426,7 +17426,7 @@
               <a:buChar char="❑"/>
             </a:pPr>
             <a:r>
-              <a:rPr lang="en-US" sz="2000" b="0" i="0" u="none">
+              <a:rPr lang="en-US" sz="2000" b="1" i="0" u="none" dirty="0">
                 <a:solidFill>
                   <a:schemeClr val="dk1"/>
                 </a:solidFill>
@@ -17437,7 +17437,7 @@
               </a:rPr>
               <a:t>Roll-forward partitioning: </a:t>
             </a:r>
-            <a:endParaRPr/>
+            <a:endParaRPr b="1" dirty="0"/>
           </a:p>
           <a:p>
             <a:pPr marL="742950" lvl="1" indent="-285750" algn="l" rtl="0">
@@ -17458,7 +17458,7 @@
               <a:buChar char="■"/>
             </a:pPr>
             <a:r>
-              <a:rPr lang="en-US" sz="1600" b="0" i="0" u="none">
+              <a:rPr lang="en-US" sz="1600" b="0" i="0" u="none" dirty="0">
                 <a:solidFill>
                   <a:schemeClr val="dk1"/>
                 </a:solidFill>
@@ -17469,7 +17469,7 @@
               </a:rPr>
               <a:t>We start with a short training period, and we gradually increase it, say by one day at a time, or by one week at a time. At each iteration, we train the model on a training period. And we use it to forecast the following day, or the following week, in the validation period</a:t>
             </a:r>
-            <a:endParaRPr/>
+            <a:endParaRPr dirty="0"/>
           </a:p>
         </p:txBody>
       </p:sp>

</xml_diff>